<commit_message>
Remove duplicate PPT file and add hypothetical company & sample data disclaimer
</commit_message>
<xml_diff>
--- a/ABC_Retail_Case_Study_Presentation.pptx
+++ b/ABC_Retail_Case_Study_Presentation.pptx
@@ -3353,12 +3353,12 @@
           <a:p>
             <a:pPr algn="ctr"/>
             <a:r>
-              <a:rPr sz="1200" b="0">
+              <a:rPr sz="1100" b="0">
                 <a:solidFill>
                   <a:srgbClr val="94A3B8"/>
                 </a:solidFill>
               </a:rPr>
-              <a:t>Marketing Mix Modeling Case Study</a:t>
+              <a:t>Marketing Intelligence Case Study  |  Note: ABC Retail is a hypothetical company name (sample data)</a:t>
             </a:r>
           </a:p>
         </p:txBody>

</xml_diff>

<commit_message>
Add Glossary of Terms section to both PPT (Slide 13) and Web Application
</commit_message>
<xml_diff>
--- a/ABC_Retail_Case_Study_Presentation.pptx
+++ b/ABC_Retail_Case_Study_Presentation.pptx
@@ -17,6 +17,7 @@
     <p:sldId id="265" r:id="rId16"/>
     <p:sldId id="266" r:id="rId17"/>
     <p:sldId id="267" r:id="rId18"/>
+    <p:sldId id="268" r:id="rId19"/>
   </p:sldIdLst>
   <p:sldSz cx="12191695" cy="6858000" type="screen4x3"/>
   <p:notesSz cx="6858000" cy="9144000"/>
@@ -4233,6 +4234,222 @@
                 </a:solidFill>
               </a:rPr>
               <a:t>Caveats: n=36, no geography/pricing/competitor data. Treat as test-and-learn priorities.</a:t>
+            </a:r>
+          </a:p>
+        </p:txBody>
+      </p:sp>
+    </p:spTree>
+  </p:cSld>
+  <p:clrMapOvr>
+    <a:masterClrMapping/>
+  </p:clrMapOvr>
+</p:sld>
+</file>
+
+<file path=ppt/slides/slide13.xml><?xml version="1.0" encoding="utf-8"?>
+<p:sld xmlns:a="http://schemas.openxmlformats.org/drawingml/2006/main" xmlns:p="http://schemas.openxmlformats.org/presentationml/2006/main" xmlns:r="http://schemas.openxmlformats.org/officeDocument/2006/relationships">
+  <p:cSld>
+    <p:bg>
+      <p:bgPr>
+        <a:solidFill>
+          <a:srgbClr val="FAFBFD"/>
+        </a:solidFill>
+        <a:effectLst/>
+      </p:bgPr>
+    </p:bg>
+    <p:spTree>
+      <p:nvGrpSpPr>
+        <p:cNvPr id="1" name=""/>
+        <p:cNvGrpSpPr/>
+        <p:nvPr/>
+      </p:nvGrpSpPr>
+      <p:grpSpPr/>
+      <p:sp>
+        <p:nvSpPr>
+          <p:cNvPr id="2" name="Rectangle 1"/>
+          <p:cNvSpPr/>
+          <p:nvPr/>
+        </p:nvSpPr>
+        <p:spPr>
+          <a:xfrm>
+            <a:off x="0" y="0"/>
+            <a:ext cx="12191695" cy="1188720"/>
+          </a:xfrm>
+          <a:prstGeom prst="rect">
+            <a:avLst/>
+          </a:prstGeom>
+          <a:solidFill>
+            <a:srgbClr val="0B1F3A"/>
+          </a:solidFill>
+          <a:ln>
+            <a:noFill/>
+          </a:ln>
+        </p:spPr>
+        <p:style>
+          <a:lnRef idx="1">
+            <a:schemeClr val="accent1"/>
+          </a:lnRef>
+          <a:fillRef idx="3">
+            <a:schemeClr val="accent1"/>
+          </a:fillRef>
+          <a:effectRef idx="2">
+            <a:schemeClr val="accent1"/>
+          </a:effectRef>
+          <a:fontRef idx="minor">
+            <a:schemeClr val="lt1"/>
+          </a:fontRef>
+        </p:style>
+        <p:txBody>
+          <a:bodyPr rtlCol="0" anchor="ctr" lIns="731520" tIns="137160"/>
+          <a:lstStyle/>
+          <a:p>
+            <a:pPr algn="l"/>
+            <a:r>
+              <a:rPr sz="2800" b="1">
+                <a:solidFill>
+                  <a:srgbClr val="FFFFFF"/>
+                </a:solidFill>
+              </a:rPr>
+              <a:t>Glossary of Marketing &amp; Econometric Terms</a:t>
+            </a:r>
+          </a:p>
+          <a:p>
+            <a:pPr algn="l"/>
+            <a:r>
+              <a:rPr sz="1400">
+                <a:solidFill>
+                  <a:srgbClr val="94A3B8"/>
+                </a:solidFill>
+              </a:rPr>
+              <a:t>Plain-English definitions &amp; real-world analogies</a:t>
+            </a:r>
+          </a:p>
+        </p:txBody>
+      </p:sp>
+      <p:sp>
+        <p:nvSpPr>
+          <p:cNvPr id="3" name="TextBox 2"/>
+          <p:cNvSpPr txBox="1"/>
+          <p:nvPr/>
+        </p:nvSpPr>
+        <p:spPr>
+          <a:xfrm>
+            <a:off x="640080" y="1554480"/>
+            <a:ext cx="10789920" cy="4846320"/>
+          </a:xfrm>
+          <a:prstGeom prst="rect">
+            <a:avLst/>
+          </a:prstGeom>
+          <a:noFill/>
+        </p:spPr>
+        <p:txBody>
+          <a:bodyPr wrap="square">
+            <a:spAutoFit/>
+          </a:bodyPr>
+          <a:lstStyle/>
+          <a:p>
+            <a:pPr>
+              <a:spcAft>
+                <a:spcPts val="600"/>
+              </a:spcAft>
+            </a:pPr>
+            <a:r>
+              <a:rPr sz="1200">
+                <a:solidFill>
+                  <a:srgbClr val="0B1F3A"/>
+                </a:solidFill>
+              </a:rPr>
+              <a:t>Adstock (Ad Memory Decay): Advertising impact does not vanish immediately; a fraction carries over into future weeks/months (e.g. coffee carryover effect).</a:t>
+            </a:r>
+          </a:p>
+          <a:p>
+            <a:pPr>
+              <a:spcAft>
+                <a:spcPts val="600"/>
+              </a:spcAft>
+            </a:pPr>
+            <a:r>
+              <a:rPr sz="1200">
+                <a:solidFill>
+                  <a:srgbClr val="0B1F3A"/>
+                </a:solidFill>
+              </a:rPr>
+              <a:t>Log-Saturation (Diminishing Returns): As ad spend increases, each additional dollar generates less sales lift because high-intent audiences become exhausted (e.g. 1st vs 10th pizza slice).</a:t>
+            </a:r>
+          </a:p>
+          <a:p>
+            <a:pPr>
+              <a:spcAft>
+                <a:spcPts val="600"/>
+              </a:spcAft>
+            </a:pPr>
+            <a:r>
+              <a:rPr sz="1200">
+                <a:solidFill>
+                  <a:srgbClr val="0B1F3A"/>
+                </a:solidFill>
+              </a:rPr>
+              <a:t>Marginal ROI: The extra revenue generated by spending the NEXT $1 today ($7.07 Radio vs $1.32 Digital). Contrasts with historical average ROI.</a:t>
+            </a:r>
+          </a:p>
+          <a:p>
+            <a:pPr>
+              <a:spcAft>
+                <a:spcPts val="600"/>
+              </a:spcAft>
+            </a:pPr>
+            <a:r>
+              <a:rPr sz="1200">
+                <a:solidFill>
+                  <a:srgbClr val="0B1F3A"/>
+                </a:solidFill>
+              </a:rPr>
+              <a:t>Standardised Coefficient (β*): Scales channel drivers from -1 to +1 so we can compare "apples to elephants" across different measurement units.</a:t>
+            </a:r>
+          </a:p>
+          <a:p>
+            <a:pPr>
+              <a:spcAft>
+                <a:spcPts val="600"/>
+              </a:spcAft>
+            </a:pPr>
+            <a:r>
+              <a:rPr sz="1200">
+                <a:solidFill>
+                  <a:srgbClr val="0B1F3A"/>
+                </a:solidFill>
+              </a:rPr>
+              <a:t>P-Value &amp; Significance: Probability that a result was caused by random luck. p &lt; 0.05 means &lt;5% chance of luck (statistically significant).</a:t>
+            </a:r>
+          </a:p>
+          <a:p>
+            <a:pPr>
+              <a:spcAft>
+                <a:spcPts val="600"/>
+              </a:spcAft>
+            </a:pPr>
+            <a:r>
+              <a:rPr sz="1200">
+                <a:solidFill>
+                  <a:srgbClr val="0B1F3A"/>
+                </a:solidFill>
+              </a:rPr>
+              <a:t>LOOCV R-Squared: Leave-One-Out Cross Validation accuracy. Tests model predictions on hidden out-of-sample data to ensure zero overfitting.</a:t>
+            </a:r>
+          </a:p>
+          <a:p>
+            <a:pPr>
+              <a:spcAft>
+                <a:spcPts val="600"/>
+              </a:spcAft>
+            </a:pPr>
+            <a:r>
+              <a:rPr sz="1200">
+                <a:solidFill>
+                  <a:srgbClr val="0B1F3A"/>
+                </a:solidFill>
+              </a:rPr>
+              <a:t>HC3 Robust Standard Errors: A small-sample correction (n=36) that prevents false-positive claims caused by unequal error variances.</a:t>
             </a:r>
           </a:p>
         </p:txBody>

</xml_diff>